<commit_message>
docs(deck): reframe 101+201 audience as showroom-for-both (no Quarkus assumed)
Align both decks' positioning with the abstract: teach data mesh from first principles AND demonstrate Quarkus as a showroom; Quarkus is the vehicle, not a prerequisite. Updated cover subtitles + opening/divider notes; softened monolith-to-microservices analogy to not assume Quarkus familiarity. Wording-only — no slides added/removed, all technical content/DRQ-015/numbers/diagrams/appendix unchanged. Rebuilt: 101=17 slides, 201=81 slides, notes==slides.
</commit_message>
<xml_diff>
--- a/presentation/datamesh-101/Datamesh_101-r1.0.pptx
+++ b/presentation/datamesh-101/Datamesh_101-r1.0.pptx
@@ -518,7 +518,7 @@
           <a:p>
             <a:r>
               <a:rPr lang="en-US" dirty="0"/>
-              <a:t>Welcome. This talk is aimed at Quarkus developers, so Quarkus is the lens we'll use throughout — but the destination is a data mesh running on Kubernetes, and the principles we cover apply regardless of runtime. We'll start with the landscape of data architectures that came before the mesh, define the mesh precisely through its four principles, then show why Quarkus and Kubernetes are a natural pairing for building one. By the end you should be able to explain what a data mesh is, when it's the right answer, and where to go deeper if you want to see one actually running.</a:t>
+              <a:t>Welcome. This talk teaches the data-mesh principles from first principles and doubles as a showroom for Quarkus — no prior Quarkus experience needed; Quarkus is the vehicle we'll demonstrate with, not a prerequisite for following along. The destination is a data mesh running on Kubernetes, and the principles we cover apply regardless of runtime. We'll start with the landscape of data architectures that came before the mesh, define the mesh precisely through its four principles, then show why Quarkus and Kubernetes are a natural pairing for building one. By the end you should be able to explain what a data mesh is, when it's the right answer, and where to go deeper if you want to see one actually running.</a:t>
             </a:r>
             <a:endParaRPr lang="en-US" dirty="0"/>
           </a:p>
@@ -694,7 +694,7 @@
           <a:p>
             <a:r>
               <a:rPr lang="en-US" dirty="0"/>
-              <a:t>This is the analogy that lands hardest with this audience. Just as a monolithic application gets refactored into bounded contexts owned by domain teams — the microservices transition most of you have already lived through — a monolithic data platform gets refactored into bounded data products owned by those same domain teams. The mesh is the network of those products plus the platform and standards that let them interoperate. The hard part was never drawing the boxes; it was deciding where one bounded context ends and the next begins, and then living with the contract at that boundary. Decomposing a data platform into data products is the identical exercise, one layer up — the boundary is now a versioned data contract instead of a REST endpoint.</a:t>
+              <a:t>This is the analogy that tends to land well for anyone who has lived through a monolith-to-microservices transition. Just as a monolithic application gets refactored into bounded contexts owned by domain teams — the microservices transition many engineers have already lived through — a monolithic data platform gets refactored into bounded data products owned by those same domain teams. The mesh is the network of those products plus the platform and standards that let them interoperate. The hard part was never drawing the boxes; it was deciding where one bounded context ends and the next begins, and then living with the contract at that boundary. Decomposing a data platform into data products is the identical exercise, one layer up — the boundary is now a versioned data contract instead of a REST endpoint.</a:t>
             </a:r>
             <a:endParaRPr lang="en-US" dirty="0"/>
           </a:p>
@@ -1926,7 +1926,7 @@
           <a:p>
             <a:r>
               <a:rPr lang="en-US" dirty="0"/>
-              <a:t>With the landscape in place, let's define data mesh precisely. Zhamak Dehghani coined the term in 2019 and formalized it in her 2022 O'Reilly book. It rests on four interlocking principles that depend on each other — implement one without the others and you get a distributed mess, not a mesh. We'll look at all four together, then at the analogy that makes them concrete for a room full of Quarkus developers: the same microservices decomposition you've already lived through, applied to data ownership instead of application code.</a:t>
+              <a:t>With the landscape in place, let's define data mesh precisely. Zhamak Dehghani coined the term in 2019 and formalized it in her 2022 O'Reilly book. It rests on four interlocking principles that depend on each other — implement one without the others and you get a distributed mess, not a mesh. We'll look at all four together, then at the analogy that makes them concrete for anyone who has lived through a monolith-to-microservices transition: the same decomposition, applied to data ownership instead of application code.</a:t>
             </a:r>
             <a:endParaRPr lang="en-US" dirty="0"/>
           </a:p>
@@ -2436,7 +2436,7 @@
                 <a:ea typeface="Red Hat Text" pitchFamily="34" charset="-122"/>
                 <a:cs typeface="Red Hat Text" pitchFamily="34" charset="-120"/>
               </a:rPr>
-              <a:t>A Quarkus developer's path from data architectures to a decentralized, domain-owned data mesh</a:t>
+              <a:t>From data-mesh principles to a running platform on Quarkus and Kubernetes — no Quarkus experience assumed</a:t>
             </a:r>
             <a:endParaRPr lang="en-US" sz="1700" dirty="0"/>
           </a:p>

</xml_diff>

<commit_message>
docs(deck): reframe 101+201 audience as showroom-for-both (no Quarkus assumed) (#16)
Align both decks' positioning with the abstract: teach data mesh from first principles AND demonstrate Quarkus as a showroom; Quarkus is the vehicle, not a prerequisite. Updated cover subtitles + opening/divider notes; softened monolith-to-microservices analogy to not assume Quarkus familiarity. Wording-only — no slides added/removed, all technical content/DRQ-015/numbers/diagrams/appendix unchanged. Rebuilt: 101=17 slides, 201=81 slides, notes==slides.
</commit_message>
<xml_diff>
--- a/presentation/datamesh-101/Datamesh_101-r1.0.pptx
+++ b/presentation/datamesh-101/Datamesh_101-r1.0.pptx
@@ -518,7 +518,7 @@
           <a:p>
             <a:r>
               <a:rPr lang="en-US" dirty="0"/>
-              <a:t>Welcome. This talk is aimed at Quarkus developers, so Quarkus is the lens we'll use throughout — but the destination is a data mesh running on Kubernetes, and the principles we cover apply regardless of runtime. We'll start with the landscape of data architectures that came before the mesh, define the mesh precisely through its four principles, then show why Quarkus and Kubernetes are a natural pairing for building one. By the end you should be able to explain what a data mesh is, when it's the right answer, and where to go deeper if you want to see one actually running.</a:t>
+              <a:t>Welcome. This talk teaches the data-mesh principles from first principles and doubles as a showroom for Quarkus — no prior Quarkus experience needed; Quarkus is the vehicle we'll demonstrate with, not a prerequisite for following along. The destination is a data mesh running on Kubernetes, and the principles we cover apply regardless of runtime. We'll start with the landscape of data architectures that came before the mesh, define the mesh precisely through its four principles, then show why Quarkus and Kubernetes are a natural pairing for building one. By the end you should be able to explain what a data mesh is, when it's the right answer, and where to go deeper if you want to see one actually running.</a:t>
             </a:r>
             <a:endParaRPr lang="en-US" dirty="0"/>
           </a:p>
@@ -694,7 +694,7 @@
           <a:p>
             <a:r>
               <a:rPr lang="en-US" dirty="0"/>
-              <a:t>This is the analogy that lands hardest with this audience. Just as a monolithic application gets refactored into bounded contexts owned by domain teams — the microservices transition most of you have already lived through — a monolithic data platform gets refactored into bounded data products owned by those same domain teams. The mesh is the network of those products plus the platform and standards that let them interoperate. The hard part was never drawing the boxes; it was deciding where one bounded context ends and the next begins, and then living with the contract at that boundary. Decomposing a data platform into data products is the identical exercise, one layer up — the boundary is now a versioned data contract instead of a REST endpoint.</a:t>
+              <a:t>This is the analogy that tends to land well for anyone who has lived through a monolith-to-microservices transition. Just as a monolithic application gets refactored into bounded contexts owned by domain teams — the microservices transition many engineers have already lived through — a monolithic data platform gets refactored into bounded data products owned by those same domain teams. The mesh is the network of those products plus the platform and standards that let them interoperate. The hard part was never drawing the boxes; it was deciding where one bounded context ends and the next begins, and then living with the contract at that boundary. Decomposing a data platform into data products is the identical exercise, one layer up — the boundary is now a versioned data contract instead of a REST endpoint.</a:t>
             </a:r>
             <a:endParaRPr lang="en-US" dirty="0"/>
           </a:p>
@@ -1926,7 +1926,7 @@
           <a:p>
             <a:r>
               <a:rPr lang="en-US" dirty="0"/>
-              <a:t>With the landscape in place, let's define data mesh precisely. Zhamak Dehghani coined the term in 2019 and formalized it in her 2022 O'Reilly book. It rests on four interlocking principles that depend on each other — implement one without the others and you get a distributed mess, not a mesh. We'll look at all four together, then at the analogy that makes them concrete for a room full of Quarkus developers: the same microservices decomposition you've already lived through, applied to data ownership instead of application code.</a:t>
+              <a:t>With the landscape in place, let's define data mesh precisely. Zhamak Dehghani coined the term in 2019 and formalized it in her 2022 O'Reilly book. It rests on four interlocking principles that depend on each other — implement one without the others and you get a distributed mess, not a mesh. We'll look at all four together, then at the analogy that makes them concrete for anyone who has lived through a monolith-to-microservices transition: the same decomposition, applied to data ownership instead of application code.</a:t>
             </a:r>
             <a:endParaRPr lang="en-US" dirty="0"/>
           </a:p>
@@ -2436,7 +2436,7 @@
                 <a:ea typeface="Red Hat Text" pitchFamily="34" charset="-122"/>
                 <a:cs typeface="Red Hat Text" pitchFamily="34" charset="-120"/>
               </a:rPr>
-              <a:t>A Quarkus developer's path from data architectures to a decentralized, domain-owned data mesh</a:t>
+              <a:t>From data-mesh principles to a running platform on Quarkus and Kubernetes — no Quarkus experience assumed</a:t>
             </a:r>
             <a:endParaRPr lang="en-US" sz="1700" dirty="0"/>
           </a:p>

</xml_diff>

<commit_message>
docs(deck): professionalize the 201 deck; add a table helper
Strip internal codes from slides and notes; move presenter cue/infra
tier/fallback logistics off slide bodies into speaker notes; drop the
honest/ALL-CAPS/reactor tics; recast the two internal-reference
appendix slides in plain language. Add a tableSlide helper (both
deck-libs) and use it for the Quarkus-vs-Spring-Boot numbers and the
engine decision guide. Light pass on the 101 deck. Both decks rebuilt.
</commit_message>
<xml_diff>
--- a/presentation/datamesh-101/Datamesh_101-r1.0.pptx
+++ b/presentation/datamesh-101/Datamesh_101-r1.0.pptx
@@ -3942,7 +3942,7 @@
                 <a:ea typeface="Overpass SemiBold" pitchFamily="34" charset="-122"/>
                 <a:cs typeface="Overpass SemiBold" pitchFamily="34" charset="-120"/>
               </a:rPr>
-              <a:t>AN HONEST CAVEAT</a:t>
+              <a:t>CHOOSING A PATTERN</a:t>
             </a:r>
             <a:endParaRPr lang="en-US" sz="1200" dirty="0"/>
           </a:p>
@@ -4184,7 +4184,7 @@
             <a:endParaRPr lang="en-US" sz="1600" dirty="0"/>
           </a:p>
           <a:p>
-            <a:pPr marL="228600" indent="-228600">
+            <a:pPr lvl="1" marL="457200" indent="-228600">
               <a:spcAft>
                 <a:spcPts val="600"/>
               </a:spcAft>
@@ -4192,7 +4192,7 @@
               <a:buChar char="•"/>
             </a:pPr>
             <a:r>
-              <a:rPr lang="en-US" sz="1600" dirty="0">
+              <a:rPr lang="en-US" sz="1500" dirty="0">
                 <a:solidFill>
                   <a:srgbClr val="151515"/>
                 </a:solidFill>
@@ -4431,7 +4431,7 @@
                 <a:ea typeface="Red Hat Text" pitchFamily="34" charset="-122"/>
                 <a:cs typeface="Red Hat Text" pitchFamily="34" charset="-120"/>
               </a:rPr>
-              <a:t>Orchestration styles in full depth, the Quarkus-vs-Spring-Boot numbers, contracts and the catalog, progressive delivery, autoscaling, and observability.</a:t>
+              <a:t>Orchestration styles, Quarkus vs. Spring Boot, contracts and the catalog, progressive delivery, autoscaling, and observability.</a:t>
             </a:r>
             <a:endParaRPr lang="en-US" sz="1600" dirty="0"/>
           </a:p>

</xml_diff>